<commit_message>
Add appendix source code, demo link, and decision boundary explanation
- Laporan: tambah Appendix source code sim_fuzzy_spk.py
- Laporan: tambah link demo Streamlit di Kesimpulan
- Laporan: tambah subsection Decision Boundary + TikZ figure
- Presentasi: tambah link demo di slide Kesimpulan
- Presentasi: slide 9 diubah jadi Decision Boundary dengan penjelasan

Co-Authored-By: Claude Opus 4.7 <noreply@anthropic.com>
</commit_message>
<xml_diff>
--- a/presentasi_cpmk2.pptx
+++ b/presentasi_cpmk2.pptx
@@ -5940,14 +5940,58 @@
       </p:sp>
       <p:sp>
         <p:nvSpPr>
-          <p:cNvPr id="20" name="TextBox 19"/>
+          <p:cNvPr id="20" name="Rounded Rectangle 19"/>
+          <p:cNvSpPr/>
+          <p:nvPr/>
+        </p:nvSpPr>
+        <p:spPr>
+          <a:xfrm>
+            <a:off x="914400" y="6263640"/>
+            <a:ext cx="10332720" cy="502920"/>
+          </a:xfrm>
+          <a:prstGeom prst="roundRect">
+            <a:avLst/>
+          </a:prstGeom>
+          <a:solidFill>
+            <a:srgbClr val="272744"/>
+          </a:solidFill>
+          <a:ln>
+            <a:noFill/>
+          </a:ln>
+          <a:effectLst/>
+        </p:spPr>
+        <p:style>
+          <a:lnRef idx="1">
+            <a:schemeClr val="accent1"/>
+          </a:lnRef>
+          <a:fillRef idx="3">
+            <a:schemeClr val="accent1"/>
+          </a:fillRef>
+          <a:effectRef idx="2">
+            <a:schemeClr val="accent1"/>
+          </a:effectRef>
+          <a:fontRef idx="minor">
+            <a:schemeClr val="lt1"/>
+          </a:fontRef>
+        </p:style>
+        <p:txBody>
+          <a:bodyPr rtlCol="0" anchor="ctr"/>
+          <a:lstStyle/>
+          <a:p>
+            <a:pPr algn="ctr"/>
+          </a:p>
+        </p:txBody>
+      </p:sp>
+      <p:sp>
+        <p:nvSpPr>
+          <p:cNvPr id="21" name="TextBox 20"/>
           <p:cNvSpPr txBox="1"/>
           <p:nvPr/>
         </p:nvSpPr>
         <p:spPr>
           <a:xfrm>
-            <a:off x="1371600" y="6400800"/>
-            <a:ext cx="9144000" cy="365760"/>
+            <a:off x="1097280" y="6309360"/>
+            <a:ext cx="7315200" cy="365760"/>
           </a:xfrm>
           <a:prstGeom prst="rect">
             <a:avLst/>
@@ -5960,8 +6004,44 @@
           </a:bodyPr>
           <a:lstStyle/>
           <a:p>
-            <a:pPr algn="ctr">
-              <a:defRPr sz="2000" b="1">
+            <a:pPr algn="l">
+              <a:defRPr sz="1300" b="0">
+                <a:solidFill>
+                  <a:srgbClr val="FFD700"/>
+                </a:solidFill>
+                <a:latin typeface="Calibri"/>
+              </a:defRPr>
+            </a:pPr>
+            <a:r>
+              <a:t>Demo interaktif: https://cpmk-02-ririx.streamlit.app/</a:t>
+            </a:r>
+          </a:p>
+        </p:txBody>
+      </p:sp>
+      <p:sp>
+        <p:nvSpPr>
+          <p:cNvPr id="22" name="TextBox 21"/>
+          <p:cNvSpPr txBox="1"/>
+          <p:nvPr/>
+        </p:nvSpPr>
+        <p:spPr>
+          <a:xfrm>
+            <a:off x="8686800" y="6309360"/>
+            <a:ext cx="2468880" cy="365760"/>
+          </a:xfrm>
+          <a:prstGeom prst="rect">
+            <a:avLst/>
+          </a:prstGeom>
+          <a:noFill/>
+        </p:spPr>
+        <p:txBody>
+          <a:bodyPr wrap="square">
+            <a:spAutoFit/>
+          </a:bodyPr>
+          <a:lstStyle/>
+          <a:p>
+            <a:pPr algn="r">
+              <a:defRPr sz="1600" b="1">
                 <a:solidFill>
                   <a:srgbClr val="FFFFFF"/>
                 </a:solidFill>
@@ -5969,7 +6049,7 @@
               </a:defRPr>
             </a:pPr>
             <a:r>
-              <a:t>Terima kasih — Ada pertanyaan?</a:t>
+              <a:t>Terima kasih!</a:t>
             </a:r>
           </a:p>
         </p:txBody>

</xml_diff>

<commit_message>
Add slide transitions and complete speaker notes Q&A sections
- Added varied transitions (fade, push, wipe, cover) to all 10 slides
- Added "APABILA DITANYAKAN" Q&A sections to slides 4, 7, 8, 9, 10
  covering: μ/membership degree, universe of discourse, overlap, MF shapes,
  diskritisasi, trapesium simetris, COG calculation, decision boundary,
  heatmap, and 10.001 points explanation

Co-Authored-By: Claude Opus 4.7 <noreply@anthropic.com>
</commit_message>
<xml_diff>
--- a/presentasi_cpmk2.pptx
+++ b/presentasi_cpmk2.pptx
@@ -685,7 +685,7 @@
           <a:p/>
           <a:p>
             <a:r>
-              <a:t>PERSIAPAN ANTISIPASI PERTANYAAN DOSEN:</a:t>
+              <a:t>APABILA DITANYAKAN:</a:t>
             </a:r>
           </a:p>
           <a:p/>
@@ -770,6 +770,47 @@
           <a:p>
             <a:r>
               <a:t>   Sistem ini bisa diupgrade dengan learning otomatis (ANFIS).</a:t>
+            </a:r>
+          </a:p>
+          <a:p/>
+          <a:p>
+            <a:r>
+              <a:t>Q: Apa maksud "10.001 titik diskritisasi" di laporan?</a:t>
+            </a:r>
+          </a:p>
+          <a:p>
+            <a:r>
+              <a:t>A: Semesta output NK (0-100) adalah kontinu. Untuk menghitung integral COG</a:t>
+            </a:r>
+          </a:p>
+          <a:p>
+            <a:r>
+              <a:t>   secara numerik, semesta ini dibagi menjadi 10.001 titik diskret dengan</a:t>
+            </a:r>
+          </a:p>
+          <a:p>
+            <a:r>
+              <a:t>   jarak (step) = 0.01. Integral kontinu di-approximate oleh metode trapezoid</a:t>
+            </a:r>
+          </a:p>
+          <a:p>
+            <a:r>
+              <a:t>   (penjumlahan ribuan trapesium kecil). Dengan step 0.01, akurasi</a:t>
+            </a:r>
+          </a:p>
+          <a:p>
+            <a:r>
+              <a:t>   defuzzifikasi &lt; 0.01 — artinya NK=75.00 bukan dibulatkan, tapi benar-benar</a:t>
+            </a:r>
+          </a:p>
+          <a:p>
+            <a:r>
+              <a:t>   hasil numerik yang presisi. Diskritisasi = mengubah kurva kontinu menjadi</a:t>
+            </a:r>
+          </a:p>
+          <a:p>
+            <a:r>
+              <a:t>   bar-chart yang sangat halus (10.001 batang).</a:t>
             </a:r>
           </a:p>
         </p:txBody>
@@ -1033,6 +1074,133 @@
               <a:t>Contoh di bawah menunjukkan end-to-end untuk data RPLD #20.</a:t>
             </a:r>
           </a:p>
+          <a:p/>
+          <a:p>
+            <a:r>
+              <a:t>---</a:t>
+            </a:r>
+          </a:p>
+          <a:p/>
+          <a:p>
+            <a:r>
+              <a:t>APABILA DITANYAKAN:</a:t>
+            </a:r>
+          </a:p>
+          <a:p/>
+          <a:p>
+            <a:r>
+              <a:t>Q: Apa itu "crisp"?</a:t>
+            </a:r>
+          </a:p>
+          <a:p>
+            <a:r>
+              <a:t>A: Crisp = nilai tegas/pasti, bukan fuzzy. Misalnya IP=3.52 adalah nilai crisp.</a:t>
+            </a:r>
+          </a:p>
+          <a:p>
+            <a:r>
+              <a:t>   Lawannya adalah nilai fuzzy yang punya derajat keanggotaan (misal μ=0.96).</a:t>
+            </a:r>
+          </a:p>
+          <a:p/>
+          <a:p>
+            <a:r>
+              <a:t>Q: α (alpha) itu apa?</a:t>
+            </a:r>
+          </a:p>
+          <a:p>
+            <a:r>
+              <a:t>A: Alpha disebut "firing strength" atau kekuatan aktivasi rule. Ini menunjukkan</a:t>
+            </a:r>
+          </a:p>
+          <a:p>
+            <a:r>
+              <a:t>   seberapa kuat sebuah rule "aktif". Dihitung dengan α = min(μ_IP, μ_Minat).</a:t>
+            </a:r>
+          </a:p>
+          <a:p>
+            <a:r>
+              <a:t>   Mengapa min? Karena dalam logika fuzzy, operator AND menggunakan min — kedua</a:t>
+            </a:r>
+          </a:p>
+          <a:p>
+            <a:r>
+              <a:t>   syarat harus terpenuhi, diambil yang paling lemah (bottleneck).</a:t>
+            </a:r>
+          </a:p>
+          <a:p/>
+          <a:p>
+            <a:r>
+              <a:t>Q: Kenapa implikasi pakai min, bukan kali (product)?</a:t>
+            </a:r>
+          </a:p>
+          <a:p>
+            <a:r>
+              <a:t>A: Min dipilih karena konsisten dengan semantik AND dalam fuzzy. Min lebih intuitif</a:t>
+            </a:r>
+          </a:p>
+          <a:p>
+            <a:r>
+              <a:t>   dan menghasilkan clipping (potongan horizontal) yang mudah divisualisasikan.</a:t>
+            </a:r>
+          </a:p>
+          <a:p>
+            <a:r>
+              <a:t>   Product (Larsen) juga valid tapi menghasilkan scaling yang lebih kompleks.</a:t>
+            </a:r>
+          </a:p>
+          <a:p/>
+          <a:p>
+            <a:r>
+              <a:t>Q: COG (Centre of Gravity) itu apa?</a:t>
+            </a:r>
+          </a:p>
+          <a:p>
+            <a:r>
+              <a:t>A: Centre of Gravity = titik pusat massa (centroid) dari area fuzzy agregasi.</a:t>
+            </a:r>
+          </a:p>
+          <a:p>
+            <a:r>
+              <a:t>   Analoginya seperti menentukan titik keseimbangan sebuah bidang datar.</a:t>
+            </a:r>
+          </a:p>
+          <a:p>
+            <a:r>
+              <a:t>   Rumusnya: COG = integral(y × μ(y)) / integral(μ(y)).</a:t>
+            </a:r>
+          </a:p>
+          <a:p>
+            <a:r>
+              <a:t>   Ini metode defuzzifikasi paling umum karena mempertimbangkan seluruh area,</a:t>
+            </a:r>
+          </a:p>
+          <a:p>
+            <a:r>
+              <a:t>   bukan hanya satu titik.</a:t>
+            </a:r>
+          </a:p>
+          <a:p/>
+          <a:p>
+            <a:r>
+              <a:t>Q: Kenapa agregasi pakai max?</a:t>
+            </a:r>
+          </a:p>
+          <a:p>
+            <a:r>
+              <a:t>A: Karena beberapa rule bisa aktif bersamaan dan menghasilkan output berbeda.</a:t>
+            </a:r>
+          </a:p>
+          <a:p>
+            <a:r>
+              <a:t>   Operator max mengambil nilai tertinggi di setiap titik — artinya rule dengan</a:t>
+            </a:r>
+          </a:p>
+          <a:p>
+            <a:r>
+              <a:t>   firing strength terbesar yang mendominasi. Ini konsisten dengan semantik OR.</a:t>
+            </a:r>
+          </a:p>
         </p:txBody>
       </p:sp>
       <p:sp>
@@ -1179,6 +1347,132 @@
               <a:t>representasi linear sudah memadai dan komputasinya lebih ringan.</a:t>
             </a:r>
           </a:p>
+          <a:p/>
+          <a:p>
+            <a:r>
+              <a:t>---</a:t>
+            </a:r>
+          </a:p>
+          <a:p/>
+          <a:p>
+            <a:r>
+              <a:t>APABILA DITANYAKAN:</a:t>
+            </a:r>
+          </a:p>
+          <a:p/>
+          <a:p>
+            <a:r>
+              <a:t>Q: μ (mu) itu apa?</a:t>
+            </a:r>
+          </a:p>
+          <a:p>
+            <a:r>
+              <a:t>A: Mu = derajat keanggotaan (membership degree), nilainya 0 sampai 1.</a:t>
+            </a:r>
+          </a:p>
+          <a:p>
+            <a:r>
+              <a:t>   μ=0 artinya "sama sekali bukan anggota", μ=1 artinya "anggota penuh",</a:t>
+            </a:r>
+          </a:p>
+          <a:p>
+            <a:r>
+              <a:t>   μ=0.8 artinya "80% menjadi anggota". Ini inti dari logika fuzzy:</a:t>
+            </a:r>
+          </a:p>
+          <a:p>
+            <a:r>
+              <a:t>   tidak hanya YA/TIDAK (0/1), tapi bisa di antaranya.</a:t>
+            </a:r>
+          </a:p>
+          <a:p/>
+          <a:p>
+            <a:r>
+              <a:t>Q: Apa itu "semesta pembicaraan" (universe of discourse)?</a:t>
+            </a:r>
+          </a:p>
+          <a:p>
+            <a:r>
+              <a:t>A: Semesta pembicaraan = rentang nilai yang valid untuk suatu variabel.</a:t>
+            </a:r>
+          </a:p>
+          <a:p>
+            <a:r>
+              <a:t>   Untuk IP: semestanya 0-4 (skala IPK di Indonesia).</a:t>
+            </a:r>
+          </a:p>
+          <a:p>
+            <a:r>
+              <a:t>   Untuk Minat: 0-4 (skala survei).</a:t>
+            </a:r>
+          </a:p>
+          <a:p>
+            <a:r>
+              <a:t>   Untuk NK: 0-100 (persentase kelayakan).</a:t>
+            </a:r>
+          </a:p>
+          <a:p>
+            <a:r>
+              <a:t>   Di luar semesta ini, μ selalu = 0.</a:t>
+            </a:r>
+          </a:p>
+          <a:p/>
+          <a:p>
+            <a:r>
+              <a:t>Q: Kenapa ada overlap antar MF?</a:t>
+            </a:r>
+          </a:p>
+          <a:p>
+            <a:r>
+              <a:t>A: Overlap memungkinkan satu nilai crisp masuk ke 2 himpunan sekaligus.</a:t>
+            </a:r>
+          </a:p>
+          <a:p>
+            <a:r>
+              <a:t>   Contoh: IP=3.40 masuk ke Cukup (μ=0.1) DAN Bagus (μ=0.8).</a:t>
+            </a:r>
+          </a:p>
+          <a:p>
+            <a:r>
+              <a:t>   Tanpa overlap, sistem tidak bisa menangkap transisi halus —</a:t>
+            </a:r>
+          </a:p>
+          <a:p>
+            <a:r>
+              <a:t>   akan seperti sistem konvensional (crisp, hanya 1 kategori).</a:t>
+            </a:r>
+          </a:p>
+          <a:p/>
+          <a:p>
+            <a:r>
+              <a:t>Q: Kenapa segitiga, bukan trapesium atau bell/Gaussian?</a:t>
+            </a:r>
+          </a:p>
+          <a:p>
+            <a:r>
+              <a:t>A: Segitiga paling sederhana, komputasi paling ringan (hanya 2 if-else),</a:t>
+            </a:r>
+          </a:p>
+          <a:p>
+            <a:r>
+              <a:t>   dan sudah cukup merepresentasikan gradasi untuk variabel akademik.</a:t>
+            </a:r>
+          </a:p>
+          <a:p>
+            <a:r>
+              <a:t>   Trapesium cocok jika ada "zona datar" (plateau), misalnya "IP 3.0-3.5</a:t>
+            </a:r>
+          </a:p>
+          <a:p>
+            <a:r>
+              <a:t>   semua dianggap bagus". Bell shape lebih mulus tapi komputasi lebih berat</a:t>
+            </a:r>
+          </a:p>
+          <a:p>
+            <a:r>
+              <a:t>   (memakai fungsi eksponensial). Untuk kebutuhan SPK ini, segitiga cukup.</a:t>
+            </a:r>
+          </a:p>
         </p:txBody>
       </p:sp>
       <p:sp>
@@ -1667,6 +1961,127 @@
               <a:t>Ini menunjukkan fuzzy system menangkap kedua faktor secara seimbang.</a:t>
             </a:r>
           </a:p>
+          <a:p/>
+          <a:p>
+            <a:r>
+              <a:t>---</a:t>
+            </a:r>
+          </a:p>
+          <a:p/>
+          <a:p>
+            <a:r>
+              <a:t>APABILA DITANYAKAN:</a:t>
+            </a:r>
+          </a:p>
+          <a:p/>
+          <a:p>
+            <a:r>
+              <a:t>Q: Kenapa RPLD NK-nya persis 75.00, bukan desimal?</a:t>
+            </a:r>
+          </a:p>
+          <a:p>
+            <a:r>
+              <a:t>A: Karena hanya 1 rule aktif (R8, α=0.80) yang menghasilkan trapesium</a:t>
+            </a:r>
+          </a:p>
+          <a:p>
+            <a:r>
+              <a:t>   simetris pada MF Tinggi (50,75,100) yang dipotong di 0.80.</a:t>
+            </a:r>
+          </a:p>
+          <a:p>
+            <a:r>
+              <a:t>   Trapesium simetris memiliki COG tepat di titik puncaknya = 75.</a:t>
+            </a:r>
+          </a:p>
+          <a:p>
+            <a:r>
+              <a:t>   Kalau ada 2+ rule aktif (seperti ITP), trapesium tidak simetris,</a:t>
+            </a:r>
+          </a:p>
+          <a:p>
+            <a:r>
+              <a:t>   sehingga COG bergeser dari 75 (ITP jadi 71.14).</a:t>
+            </a:r>
+          </a:p>
+          <a:p/>
+          <a:p>
+            <a:r>
+              <a:t>Q: Apa itu "trapesium simetris"?</a:t>
+            </a:r>
+          </a:p>
+          <a:p>
+            <a:r>
+              <a:t>A: Ketika MF segitiga Tinggi(50,75,100) dipotong horizontal di α=0.80,</a:t>
+            </a:r>
+          </a:p>
+          <a:p>
+            <a:r>
+              <a:t>   bentuknya menjadi trapesium dengan sisi kiri dan kanan sama panjang.</a:t>
+            </a:r>
+          </a:p>
+          <a:p>
+            <a:r>
+              <a:t>   Titik pusat massa (COG) trapesium simetris = titik puncak segitiga asli.</a:t>
+            </a:r>
+          </a:p>
+          <a:p>
+            <a:r>
+              <a:t>   Itu kenapa RPLD = persis 75.</a:t>
+            </a:r>
+          </a:p>
+          <a:p/>
+          <a:p>
+            <a:r>
+              <a:t>Q: Kenapa ITP punya 2 rule aktif tapi NK-nya lebih rendah dari RPLD?</a:t>
+            </a:r>
+          </a:p>
+          <a:p>
+            <a:r>
+              <a:t>A: ITP mengaktifkan R5 (Sedang, α=0.1) dan R8 (Tinggi, α=0.6).</a:t>
+            </a:r>
+          </a:p>
+          <a:p>
+            <a:r>
+              <a:t>   Agregasi max menghasilkan area dengan puncak di Tinggi, tapi</a:t>
+            </a:r>
+          </a:p>
+          <a:p>
+            <a:r>
+              <a:t>   bagian Sedang (kiri) menarik COG ke kiri, sehingga turun dari 75 → 71.14.</a:t>
+            </a:r>
+          </a:p>
+          <a:p>
+            <a:r>
+              <a:t>   RPLD hanya mengaktifkan R8 dengan α lebih tinggi (0.80), murni Tinggi.</a:t>
+            </a:r>
+          </a:p>
+          <a:p/>
+          <a:p>
+            <a:r>
+              <a:t>Q: Bagaimana COG dihitung secara numerik?</a:t>
+            </a:r>
+          </a:p>
+          <a:p>
+            <a:r>
+              <a:t>A: COG = integral(y × μ(y) dy) / integral(μ(y) dy).</a:t>
+            </a:r>
+          </a:p>
+          <a:p>
+            <a:r>
+              <a:t>   Dalam kode, semesta NK (0-100) didiskritisasi menjadi 10.001 titik</a:t>
+            </a:r>
+          </a:p>
+          <a:p>
+            <a:r>
+              <a:t>   dengan step=0.01. Integral dihitung dengan metode trapezoid.</a:t>
+            </a:r>
+          </a:p>
+          <a:p>
+            <a:r>
+              <a:t>   10.001 titik dipilih agar error numerik &lt; 0.01 (sub-pixel).</a:t>
+            </a:r>
+          </a:p>
         </p:txBody>
       </p:sp>
       <p:sp>
@@ -1801,6 +2216,147 @@
               <a:t>dengan 10.001 titik diskritisasi untuk akurasi numerik.</a:t>
             </a:r>
           </a:p>
+          <a:p/>
+          <a:p>
+            <a:r>
+              <a:t>---</a:t>
+            </a:r>
+          </a:p>
+          <a:p/>
+          <a:p>
+            <a:r>
+              <a:t>APABILA DITANYAKAN:</a:t>
+            </a:r>
+          </a:p>
+          <a:p/>
+          <a:p>
+            <a:r>
+              <a:t>Q: Apa maksud "10.001 titik diskritisasi"?</a:t>
+            </a:r>
+          </a:p>
+          <a:p>
+            <a:r>
+              <a:t>A: Semesta output NK adalah kontinu (0 sampai 100). Untuk menghitung COG</a:t>
+            </a:r>
+          </a:p>
+          <a:p>
+            <a:r>
+              <a:t>   secara numerik, kita membagi semesta ini menjadi titik-titik diskret.</a:t>
+            </a:r>
+          </a:p>
+          <a:p>
+            <a:r>
+              <a:t>   10.001 titik artinya step = 100/10000 = 0.01. Jadi kita evaluasi</a:t>
+            </a:r>
+          </a:p>
+          <a:p>
+            <a:r>
+              <a:t>   μ(y) di y = 0.00, 0.01, 0.02, ..., 99.99, 100.00.</a:t>
+            </a:r>
+          </a:p>
+          <a:p>
+            <a:r>
+              <a:t>   Integral kontinu dihitung dengan metode trapezoid (penjumlahan area</a:t>
+            </a:r>
+          </a:p>
+          <a:p>
+            <a:r>
+              <a:t>   trapesium kecil). Dengan step 0.01, error numerik &lt; 0.01 (sub-pixel).</a:t>
+            </a:r>
+          </a:p>
+          <a:p/>
+          <a:p>
+            <a:r>
+              <a:t>Q: Kenapa 10.001, bukan 1.001 atau 100.001?</a:t>
+            </a:r>
+          </a:p>
+          <a:p>
+            <a:r>
+              <a:t>A: 1.001 titik (step=0.1) → error sekitar 0.1, masih kasar.</a:t>
+            </a:r>
+          </a:p>
+          <a:p>
+            <a:r>
+              <a:t>   10.001 titik (step=0.01) → error &lt; 0.01, akurat untuk 2 desimal.</a:t>
+            </a:r>
+          </a:p>
+          <a:p>
+            <a:r>
+              <a:t>   100.001 titik → error &lt; 0.001, tapi komputasi 10x lebih berat</a:t>
+            </a:r>
+          </a:p>
+          <a:p>
+            <a:r>
+              <a:t>   tanpa perbaikan signifikan. 10.001 adalah titik manis (sweet spot).</a:t>
+            </a:r>
+          </a:p>
+          <a:p/>
+          <a:p>
+            <a:r>
+              <a:t>Q: "Diskritisasi" itu apa?</a:t>
+            </a:r>
+          </a:p>
+          <a:p>
+            <a:r>
+              <a:t>A: Diskritisasi = mengubah sesuatu yang kontinu (rangenya tak terhingga)</a:t>
+            </a:r>
+          </a:p>
+          <a:p>
+            <a:r>
+              <a:t>   menjadi titik-titik diskret (berhingga). Analoginya: kurva kontinu</a:t>
+            </a:r>
+          </a:p>
+          <a:p>
+            <a:r>
+              <a:t>   di-approximate oleh bar-chart yang sangat halus. Semakin banyak titik,</a:t>
+            </a:r>
+          </a:p>
+          <a:p>
+            <a:r>
+              <a:t>   semakin mendekati kurva aslinya. 10.001 titik membuat bar-chart</a:t>
+            </a:r>
+          </a:p>
+          <a:p>
+            <a:r>
+              <a:t>   terlihat seperti kurva mulus.</a:t>
+            </a:r>
+          </a:p>
+          <a:p/>
+          <a:p>
+            <a:r>
+              <a:t>Q: Kenapa akurasi 100%? Apakah overfitting?</a:t>
+            </a:r>
+          </a:p>
+          <a:p>
+            <a:r>
+              <a:t>A: Bukan overfitting karena ini BUKAN machine learning. Ini FIS Mamdani</a:t>
+            </a:r>
+          </a:p>
+          <a:p>
+            <a:r>
+              <a:t>   (rule-based). 100% akurat karena rules dirancang berdasarkan logika</a:t>
+            </a:r>
+          </a:p>
+          <a:p>
+            <a:r>
+              <a:t>   yang konsisten: jika IP dan Minat tinggi → NK tinggi. Data survei</a:t>
+            </a:r>
+          </a:p>
+          <a:p>
+            <a:r>
+              <a:t>   memang mengikuti pola ini. FIS Mamdani tidak "belajar" dari data,</a:t>
+            </a:r>
+          </a:p>
+          <a:p>
+            <a:r>
+              <a:t>   tapi menerapkan aturan yang kita tentukan. 100% berarti rules</a:t>
+            </a:r>
+          </a:p>
+          <a:p>
+            <a:r>
+              <a:t>   konsisten dengan pola data.</a:t>
+            </a:r>
+          </a:p>
         </p:txBody>
       </p:sp>
       <p:sp>
@@ -1969,6 +2525,127 @@
           <a:p>
             <a:r>
               <a:t>bukan hanya mengambil IP tertinggi.</a:t>
+            </a:r>
+          </a:p>
+          <a:p/>
+          <a:p>
+            <a:r>
+              <a:t>---</a:t>
+            </a:r>
+          </a:p>
+          <a:p/>
+          <a:p>
+            <a:r>
+              <a:t>APABILA DITANYAKAN:</a:t>
+            </a:r>
+          </a:p>
+          <a:p/>
+          <a:p>
+            <a:r>
+              <a:t>Q: "Decision boundary" itu apa?</a:t>
+            </a:r>
+          </a:p>
+          <a:p>
+            <a:r>
+              <a:t>A: Decision boundary = batas keputusan, yaitu garis/kurva yang memisahkan</a:t>
+            </a:r>
+          </a:p>
+          <a:p>
+            <a:r>
+              <a:t>   wilayah dengan output berbeda. Di sini, wilayah hijau (NK tinggi) vs</a:t>
+            </a:r>
+          </a:p>
+          <a:p>
+            <a:r>
+              <a:t>   merah (NK rendah) dipisahkan oleh "batas" yang ditentukan oleh rules.</a:t>
+            </a:r>
+          </a:p>
+          <a:p>
+            <a:r>
+              <a:t>   Istilah ini dipinjam dari machine learning, tapi konsepnya sama:</a:t>
+            </a:r>
+          </a:p>
+          <a:p>
+            <a:r>
+              <a:t>   pemetaan dari input space ke output regions.</a:t>
+            </a:r>
+          </a:p>
+          <a:p/>
+          <a:p>
+            <a:r>
+              <a:t>Q: Apa itu "heatmap" / "contour"?</a:t>
+            </a:r>
+          </a:p>
+          <a:p>
+            <a:r>
+              <a:t>A: Heatmap = peta warna, di mana setiap piksel diwarnai berdasarkan nilai NK.</a:t>
+            </a:r>
+          </a:p>
+          <a:p>
+            <a:r>
+              <a:t>   Merah = NK rendah, hijau = NK tinggi. Dihasilkan dengan menghitung</a:t>
+            </a:r>
+          </a:p>
+          <a:p>
+            <a:r>
+              <a:t>   FIS Mamdani untuk setiap titik grid (40×40 = 1.600 kombinasi IP/Minat).</a:t>
+            </a:r>
+          </a:p>
+          <a:p>
+            <a:r>
+              <a:t>   Contour = garis yang menghubungkan titik dengan nilai sama (iso-NK).</a:t>
+            </a:r>
+          </a:p>
+          <a:p/>
+          <a:p>
+            <a:r>
+              <a:t>Q: Kenapa threshold NK=50 dan NK=75 yang dipilih?</a:t>
+            </a:r>
+          </a:p>
+          <a:p>
+            <a:r>
+              <a:t>A: Karena parameter MF output (NK): Rendah berpuncak di 25, Sedang di 50,</a:t>
+            </a:r>
+          </a:p>
+          <a:p>
+            <a:r>
+              <a:t>   Tinggi di 75. Garis NK=50 memisahkan "rendah vs sedang",</a:t>
+            </a:r>
+          </a:p>
+          <a:p>
+            <a:r>
+              <a:t>   garis NK=75 memisahkan "sedang vs tinggi". Ini BUKAN threshold</a:t>
+            </a:r>
+          </a:p>
+          <a:p>
+            <a:r>
+              <a:t>   yang ditetapkan manual, tapi konsekuensi dari parameter MF output.</a:t>
+            </a:r>
+          </a:p>
+          <a:p/>
+          <a:p>
+            <a:r>
+              <a:t>Q: Bagaimana heatmap ini dibuat?</a:t>
+            </a:r>
+          </a:p>
+          <a:p>
+            <a:r>
+              <a:t>A: Saya membuat grid 40×40 pada rentang IP=[0,4] dan Minat=[0,4].</a:t>
+            </a:r>
+          </a:p>
+          <a:p>
+            <a:r>
+              <a:t>   Untuk setiap titik grid, saya jalankan FIS Mamdani → dapat NK.</a:t>
+            </a:r>
+          </a:p>
+          <a:p>
+            <a:r>
+              <a:t>   Lalu NK di-mapping ke warna (merah-kuning-hijau).</a:t>
+            </a:r>
+          </a:p>
+          <a:p>
+            <a:r>
+              <a:t>   Total 1.600 evaluasi FIS, selesai dalam hitungan detik.</a:t>
             </a:r>
           </a:p>
         </p:txBody>
@@ -5150,6 +5827,9 @@
   <p:clrMapOvr>
     <a:masterClrMapping/>
   </p:clrMapOvr>
+  <p:transition p:spd="med">
+    <p:fade p:thruBlk="1"/>
+  </p:transition>
 </p:sld>
 </file>
 
@@ -6059,6 +6739,9 @@
   <p:clrMapOvr>
     <a:masterClrMapping/>
   </p:clrMapOvr>
+  <p:transition p:spd="med">
+    <p:fade p:thruBlk="1"/>
+  </p:transition>
 </p:sld>
 </file>
 
@@ -6485,6 +7168,9 @@
   <p:clrMapOvr>
     <a:masterClrMapping/>
   </p:clrMapOvr>
+  <p:transition p:spd="med">
+    <p:push p:dir="r"/>
+  </p:transition>
 </p:sld>
 </file>
 
@@ -7738,6 +8424,9 @@
   <p:clrMapOvr>
     <a:masterClrMapping/>
   </p:clrMapOvr>
+  <p:transition p:spd="med">
+    <p:wipe p:dir="r"/>
+  </p:transition>
 </p:sld>
 </file>
 
@@ -8135,6 +8824,9 @@
   <p:clrMapOvr>
     <a:masterClrMapping/>
   </p:clrMapOvr>
+  <p:transition p:spd="med">
+    <p:cover p:dir="l"/>
+  </p:transition>
 </p:sld>
 </file>
 
@@ -9786,6 +10478,9 @@
   <p:clrMapOvr>
     <a:masterClrMapping/>
   </p:clrMapOvr>
+  <p:transition p:spd="med">
+    <p:fade p:thruBlk="1"/>
+  </p:transition>
 </p:sld>
 </file>
 
@@ -10548,6 +11243,9 @@
   <p:clrMapOvr>
     <a:masterClrMapping/>
   </p:clrMapOvr>
+  <p:transition p:spd="med">
+    <p:push p:dir="r"/>
+  </p:transition>
 </p:sld>
 </file>
 
@@ -11817,6 +12515,9 @@
   <p:clrMapOvr>
     <a:masterClrMapping/>
   </p:clrMapOvr>
+  <p:transition p:spd="med">
+    <p:wipe p:dir="r"/>
+  </p:transition>
 </p:sld>
 </file>
 
@@ -12202,6 +12903,9 @@
   <p:clrMapOvr>
     <a:masterClrMapping/>
   </p:clrMapOvr>
+  <p:transition p:spd="med">
+    <p:cover p:dir="l"/>
+  </p:transition>
 </p:sld>
 </file>
 
@@ -12761,6 +13465,9 @@
   <p:clrMapOvr>
     <a:masterClrMapping/>
   </p:clrMapOvr>
+  <p:transition p:spd="med">
+    <p:fade p:thruBlk="1"/>
+  </p:transition>
 </p:sld>
 </file>
 

</xml_diff>